<commit_message>
Remove requested support from judge materials
</commit_message>
<xml_diff>
--- a/presentation/GeoGuard.pptx
+++ b/presentation/GeoGuard.pptx
@@ -2,25 +2,25 @@
 <file path=ppt/presentation.xml><?xml version="1.0" encoding="utf-8"?>
 <p:presentation xmlns:p="http://schemas.openxmlformats.org/presentationml/2006/main">
   <p:sldMasterIdLst>
-    <p:sldMasterId xmlns:r="http://schemas.openxmlformats.org/officeDocument/2006/relationships" id="2147483648" r:id="R59753d3cbd3b4160"/>
+    <p:sldMasterId xmlns:r="http://schemas.openxmlformats.org/officeDocument/2006/relationships" id="2147483648" r:id="Rcf042a5b33e44554"/>
   </p:sldMasterIdLst>
   <p:notesMasterIdLst>
-    <p:notesMasterId xmlns:r="http://schemas.openxmlformats.org/officeDocument/2006/relationships" r:id="R8aa82f9e74a14696"/>
+    <p:notesMasterId xmlns:r="http://schemas.openxmlformats.org/officeDocument/2006/relationships" r:id="Ra0e13f9b86e040c6"/>
   </p:notesMasterIdLst>
   <p:sldIdLst>
-    <p:sldId xmlns:r="http://schemas.openxmlformats.org/officeDocument/2006/relationships" id="256" r:id="R3d62b40e5427459b"/>
-    <p:sldId xmlns:r="http://schemas.openxmlformats.org/officeDocument/2006/relationships" id="257" r:id="R95fad0d398a84dee"/>
-    <p:sldId xmlns:r="http://schemas.openxmlformats.org/officeDocument/2006/relationships" id="258" r:id="R01be252ab9074992"/>
-    <p:sldId xmlns:r="http://schemas.openxmlformats.org/officeDocument/2006/relationships" id="259" r:id="Rda825094e9294128"/>
-    <p:sldId xmlns:r="http://schemas.openxmlformats.org/officeDocument/2006/relationships" id="260" r:id="Re94d39905815428a"/>
-    <p:sldId xmlns:r="http://schemas.openxmlformats.org/officeDocument/2006/relationships" id="261" r:id="R9b9bebaff3834896"/>
-    <p:sldId xmlns:r="http://schemas.openxmlformats.org/officeDocument/2006/relationships" id="262" r:id="R8d52800434a34079"/>
-    <p:sldId xmlns:r="http://schemas.openxmlformats.org/officeDocument/2006/relationships" id="263" r:id="R835c13802a064267"/>
-    <p:sldId xmlns:r="http://schemas.openxmlformats.org/officeDocument/2006/relationships" id="264" r:id="R79926f1bf45f435d"/>
-    <p:sldId xmlns:r="http://schemas.openxmlformats.org/officeDocument/2006/relationships" id="265" r:id="Re7fd04ecfc734bb2"/>
-    <p:sldId xmlns:r="http://schemas.openxmlformats.org/officeDocument/2006/relationships" id="266" r:id="R414d5e84c67b4133"/>
-    <p:sldId xmlns:r="http://schemas.openxmlformats.org/officeDocument/2006/relationships" id="267" r:id="R21b2fcb3490c41fc"/>
-    <p:sldId xmlns:r="http://schemas.openxmlformats.org/officeDocument/2006/relationships" id="268" r:id="R81e007cfdf0d41e4"/>
+    <p:sldId xmlns:r="http://schemas.openxmlformats.org/officeDocument/2006/relationships" id="256" r:id="R5e63187618f64d5b"/>
+    <p:sldId xmlns:r="http://schemas.openxmlformats.org/officeDocument/2006/relationships" id="257" r:id="R1e3982195ce74dd5"/>
+    <p:sldId xmlns:r="http://schemas.openxmlformats.org/officeDocument/2006/relationships" id="258" r:id="R1e1083055dc24e2f"/>
+    <p:sldId xmlns:r="http://schemas.openxmlformats.org/officeDocument/2006/relationships" id="259" r:id="R19c1444e0291443e"/>
+    <p:sldId xmlns:r="http://schemas.openxmlformats.org/officeDocument/2006/relationships" id="260" r:id="Rb8acc2b0c4c34000"/>
+    <p:sldId xmlns:r="http://schemas.openxmlformats.org/officeDocument/2006/relationships" id="261" r:id="Read0f22d825e42ed"/>
+    <p:sldId xmlns:r="http://schemas.openxmlformats.org/officeDocument/2006/relationships" id="262" r:id="Re598ebfb36a64308"/>
+    <p:sldId xmlns:r="http://schemas.openxmlformats.org/officeDocument/2006/relationships" id="263" r:id="R3eecb4aab4f74cba"/>
+    <p:sldId xmlns:r="http://schemas.openxmlformats.org/officeDocument/2006/relationships" id="264" r:id="R97fcec9305884d74"/>
+    <p:sldId xmlns:r="http://schemas.openxmlformats.org/officeDocument/2006/relationships" id="265" r:id="R0f9a7b45a6e54b48"/>
+    <p:sldId xmlns:r="http://schemas.openxmlformats.org/officeDocument/2006/relationships" id="266" r:id="R23e05ad03a414190"/>
+    <p:sldId xmlns:r="http://schemas.openxmlformats.org/officeDocument/2006/relationships" id="267" r:id="R124cc0cba99a432b"/>
+    <p:sldId xmlns:r="http://schemas.openxmlformats.org/officeDocument/2006/relationships" id="268" r:id="R2177c7635e7a45b8"/>
   </p:sldIdLst>
   <p:sldSz cx="12192000" cy="6858000"/>
   <p:notesSz cx="6858000" cy="9144000"/>
@@ -1412,7 +1412,7 @@
   </p:cSld>
   <p:clrMap bg1="lt1" tx1="dk1" bg2="lt2" tx2="dk2" accent1="accent1" accent2="accent2" accent3="accent3" accent4="accent4" accent5="accent5" accent6="accent6" hlink="hlink" folHlink="folHlink"/>
   <p:sldLayoutIdLst>
-    <p:sldLayoutId xmlns:r="http://schemas.openxmlformats.org/officeDocument/2006/relationships" id="2147483649" r:id="R01131c271cc24342"/>
+    <p:sldLayoutId xmlns:r="http://schemas.openxmlformats.org/officeDocument/2006/relationships" id="2147483649" r:id="R8d89c74faf0c4536"/>
   </p:sldLayoutIdLst>
   <p:txStyles>
     <p:titleStyle>
@@ -3488,7 +3488,7 @@
                 <a:ea typeface="Arial"/>
                 <a:cs typeface="Arial"/>
               </a:rPr>
-              <a:t>Team and pilot support</a:t>
+              <a:t>Team and demonstration</a:t>
             </a:r>
           </a:p>
         </p:txBody>
@@ -4054,7 +4054,7 @@
                 <a:ea typeface="Arial"/>
                 <a:cs typeface="Arial"/>
               </a:rPr>
-              <a:t>Requested support</a:t>
+              <a:t/>
             </a:r>
           </a:p>
         </p:txBody>
@@ -4094,7 +4094,7 @@
           <a:p xmlns:a="http://schemas.openxmlformats.org/drawingml/2006/main">
             <a:pPr>
               <a:buNone/>
-              <a:defRPr sz="2025" b="0">
+              <a:defRPr sz="2625" b="0">
                 <a:solidFill>
                   <a:srgbClr val="0C554E"/>
                 </a:solidFill>
@@ -4104,7 +4104,7 @@
               </a:defRPr>
             </a:pPr>
             <a:r>
-              <a:rPr sz="2025" b="0">
+              <a:rPr sz="2625" b="0">
                 <a:solidFill>
                   <a:srgbClr val="0C554E"/>
                 </a:solidFill>
@@ -4112,7 +4112,7 @@
                 <a:ea typeface="Arial"/>
                 <a:cs typeface="Arial"/>
               </a:rPr>
-              <a:t>A monitoring partner, independently reviewed cases and analyst feedback</a:t>
+              <a:t/>
             </a:r>
           </a:p>
         </p:txBody>
@@ -5467,7 +5467,7 @@
           <p:cNvPr id="9" name="">
             <a:extLst xmlns:a="http://schemas.openxmlformats.org/drawingml/2006/main">
               <a:ext uri="{FF2B5EF4-FFF2-40B4-BE49-F238E27FC236}">
-                <a16:creationId xmlns:a16="http://schemas.microsoft.com/office/drawing/2014/main" id="{E106C940-DD0D-4ACF-8723-E84499939F3D}"/>
+                <a16:creationId xmlns:a16="http://schemas.microsoft.com/office/drawing/2014/main" id="{10498C99-3141-4A09-BA9E-F806E61FE6AA}"/>
               </a:ext>
             </a:extLst>
           </p:cNvPr>
@@ -5524,7 +5524,7 @@
           <p:cNvPr id="2" name="">
             <a:extLst xmlns:a="http://schemas.openxmlformats.org/drawingml/2006/main">
               <a:ext uri="{FF2B5EF4-FFF2-40B4-BE49-F238E27FC236}">
-                <a16:creationId xmlns:a16="http://schemas.microsoft.com/office/drawing/2014/main" id="{70AC330C-6C7F-4CDD-AFB8-B03E58F64314}"/>
+                <a16:creationId xmlns:a16="http://schemas.microsoft.com/office/drawing/2014/main" id="{7829CE5C-688D-4971-8112-F57F68EBDC95}"/>
               </a:ext>
             </a:extLst>
           </p:cNvPr>
@@ -5554,7 +5554,7 @@
           <p:cNvPr id="3" name="">
             <a:extLst xmlns:a="http://schemas.openxmlformats.org/drawingml/2006/main">
               <a:ext uri="{FF2B5EF4-FFF2-40B4-BE49-F238E27FC236}">
-                <a16:creationId xmlns:a16="http://schemas.microsoft.com/office/drawing/2014/main" id="{B1285734-D2FD-492F-A607-58F340E31656}"/>
+                <a16:creationId xmlns:a16="http://schemas.microsoft.com/office/drawing/2014/main" id="{4A263D63-C7EA-4D3F-B5A5-8F27F656E959}"/>
               </a:ext>
             </a:extLst>
           </p:cNvPr>
@@ -5611,7 +5611,7 @@
           <p:cNvPr id="4" name="">
             <a:extLst xmlns:a="http://schemas.openxmlformats.org/drawingml/2006/main">
               <a:ext uri="{FF2B5EF4-FFF2-40B4-BE49-F238E27FC236}">
-                <a16:creationId xmlns:a16="http://schemas.microsoft.com/office/drawing/2014/main" id="{41CB3B77-5E1D-4204-8D4E-27DEA9E0F0EB}"/>
+                <a16:creationId xmlns:a16="http://schemas.microsoft.com/office/drawing/2014/main" id="{9D5B664F-148F-4F5C-8422-5E9D99742646}"/>
               </a:ext>
             </a:extLst>
           </p:cNvPr>
@@ -5668,7 +5668,7 @@
           <p:cNvPr id="5" name="">
             <a:extLst xmlns:a="http://schemas.openxmlformats.org/drawingml/2006/main">
               <a:ext uri="{FF2B5EF4-FFF2-40B4-BE49-F238E27FC236}">
-                <a16:creationId xmlns:a16="http://schemas.microsoft.com/office/drawing/2014/main" id="{1D8EA754-9C5A-468D-800A-D28E1BA574AB}"/>
+                <a16:creationId xmlns:a16="http://schemas.microsoft.com/office/drawing/2014/main" id="{4E82C12F-71C3-44B2-A336-B334EF74AE70}"/>
               </a:ext>
             </a:extLst>
           </p:cNvPr>
@@ -5776,7 +5776,7 @@
           <p:cNvPr id="6" name="">
             <a:extLst xmlns:a="http://schemas.openxmlformats.org/drawingml/2006/main">
               <a:ext uri="{FF2B5EF4-FFF2-40B4-BE49-F238E27FC236}">
-                <a16:creationId xmlns:a16="http://schemas.microsoft.com/office/drawing/2014/main" id="{A1D169F1-4D32-44CD-83D3-992535DA137B}"/>
+                <a16:creationId xmlns:a16="http://schemas.microsoft.com/office/drawing/2014/main" id="{98B6A8A2-5115-4C48-AECD-5203F78FF89B}"/>
               </a:ext>
             </a:extLst>
           </p:cNvPr>
@@ -5833,7 +5833,7 @@
           <p:cNvPr id="7" name="">
             <a:extLst xmlns:a="http://schemas.openxmlformats.org/drawingml/2006/main">
               <a:ext uri="{FF2B5EF4-FFF2-40B4-BE49-F238E27FC236}">
-                <a16:creationId xmlns:a16="http://schemas.microsoft.com/office/drawing/2014/main" id="{54820E75-07D2-4CE4-9067-183B56A4EB1B}"/>
+                <a16:creationId xmlns:a16="http://schemas.microsoft.com/office/drawing/2014/main" id="{F85FE87D-9B21-4051-B331-064C59F94BB8}"/>
               </a:ext>
             </a:extLst>
           </p:cNvPr>
@@ -5946,7 +5946,7 @@
           <p:cNvPr id="8" name="">
             <a:extLst xmlns:a="http://schemas.openxmlformats.org/drawingml/2006/main">
               <a:ext uri="{FF2B5EF4-FFF2-40B4-BE49-F238E27FC236}">
-                <a16:creationId xmlns:a16="http://schemas.microsoft.com/office/drawing/2014/main" id="{38AF1D14-4179-4CAE-A90F-BEC2DAE8E823}"/>
+                <a16:creationId xmlns:a16="http://schemas.microsoft.com/office/drawing/2014/main" id="{7E81C113-63D3-4582-986C-DC9F26B90BC5}"/>
               </a:ext>
             </a:extLst>
           </p:cNvPr>
@@ -6024,7 +6024,7 @@
     </p:spTree>
     <p:extLst>
       <p:ext uri="{BB962C8B-B14F-4D97-AF65-F5344CB8AC3E}">
-        <p14:creationId xmlns:p14="http://schemas.microsoft.com/office/powerpoint/2010/main" val="993510542"/>
+        <p14:creationId xmlns:p14="http://schemas.microsoft.com/office/powerpoint/2010/main" val="1192729649"/>
       </p:ext>
     </p:extLst>
   </p:cSld>
@@ -9032,7 +9032,7 @@
           <p:nvPr/>
         </p:nvPicPr>
         <p:blipFill>
-          <a:blip xmlns:r="http://schemas.openxmlformats.org/officeDocument/2006/relationships" xmlns:a="http://schemas.openxmlformats.org/drawingml/2006/main" r:embed="R04c2459abb234318"/>
+          <a:blip xmlns:r="http://schemas.openxmlformats.org/officeDocument/2006/relationships" xmlns:a="http://schemas.openxmlformats.org/drawingml/2006/main" r:embed="R5befafd6b5214306"/>
           <a:stretch xmlns:a="http://schemas.openxmlformats.org/drawingml/2006/main"/>
         </p:blipFill>
         <p:spPr>
@@ -10298,7 +10298,7 @@
           <p:cNvPr id="8" name="">
             <a:extLst xmlns:a="http://schemas.openxmlformats.org/drawingml/2006/main">
               <a:ext uri="{FF2B5EF4-FFF2-40B4-BE49-F238E27FC236}">
-                <a16:creationId xmlns:a16="http://schemas.microsoft.com/office/drawing/2014/main" id="{7271D439-67E0-48EF-B59F-0CBD49AB2BD3}"/>
+                <a16:creationId xmlns:a16="http://schemas.microsoft.com/office/drawing/2014/main" id="{0A78F1A3-1468-4515-8135-F75E0C15D35A}"/>
               </a:ext>
             </a:extLst>
           </p:cNvPr>
@@ -10355,7 +10355,7 @@
           <p:cNvPr id="2" name="">
             <a:extLst xmlns:a="http://schemas.openxmlformats.org/drawingml/2006/main">
               <a:ext uri="{FF2B5EF4-FFF2-40B4-BE49-F238E27FC236}">
-                <a16:creationId xmlns:a16="http://schemas.microsoft.com/office/drawing/2014/main" id="{01163914-2F62-4F44-B55C-A3CD864D3D78}"/>
+                <a16:creationId xmlns:a16="http://schemas.microsoft.com/office/drawing/2014/main" id="{3E1B28E4-49FB-4AF1-A3D5-9BDDB5B23DFC}"/>
               </a:ext>
             </a:extLst>
           </p:cNvPr>
@@ -10385,7 +10385,7 @@
           <p:cNvPr id="3" name="">
             <a:extLst xmlns:a="http://schemas.openxmlformats.org/drawingml/2006/main">
               <a:ext uri="{FF2B5EF4-FFF2-40B4-BE49-F238E27FC236}">
-                <a16:creationId xmlns:a16="http://schemas.microsoft.com/office/drawing/2014/main" id="{BA5FFF62-E3E8-4286-A7E3-0D4464712582}"/>
+                <a16:creationId xmlns:a16="http://schemas.microsoft.com/office/drawing/2014/main" id="{B000BB5C-5F90-4488-80EA-2FBC6BD83157}"/>
               </a:ext>
             </a:extLst>
           </p:cNvPr>
@@ -10446,7 +10446,7 @@
           <p:nvPr/>
         </p:nvPicPr>
         <p:blipFill>
-          <a:blip xmlns:r="http://schemas.openxmlformats.org/officeDocument/2006/relationships" xmlns:a="http://schemas.openxmlformats.org/drawingml/2006/main" r:embed="Ra8013aadfb314f53"/>
+          <a:blip xmlns:r="http://schemas.openxmlformats.org/officeDocument/2006/relationships" xmlns:a="http://schemas.openxmlformats.org/drawingml/2006/main" r:embed="Re1b366e8d25443df"/>
           <a:stretch xmlns:a="http://schemas.openxmlformats.org/drawingml/2006/main"/>
         </p:blipFill>
         <p:spPr>
@@ -10464,7 +10464,7 @@
           <p:cNvPr id="5" name="">
             <a:extLst xmlns:a="http://schemas.openxmlformats.org/drawingml/2006/main">
               <a:ext uri="{FF2B5EF4-FFF2-40B4-BE49-F238E27FC236}">
-                <a16:creationId xmlns:a16="http://schemas.microsoft.com/office/drawing/2014/main" id="{71BA24F5-3393-4F39-81CB-3ECD95AD7627}"/>
+                <a16:creationId xmlns:a16="http://schemas.microsoft.com/office/drawing/2014/main" id="{566DA33E-7004-40C1-BE1A-AFA0F0D27875}"/>
               </a:ext>
             </a:extLst>
           </p:cNvPr>
@@ -10521,7 +10521,7 @@
           <p:cNvPr id="6" name="">
             <a:extLst xmlns:a="http://schemas.openxmlformats.org/drawingml/2006/main">
               <a:ext uri="{FF2B5EF4-FFF2-40B4-BE49-F238E27FC236}">
-                <a16:creationId xmlns:a16="http://schemas.microsoft.com/office/drawing/2014/main" id="{F354465E-A97E-450C-99A1-ED8E989595EB}"/>
+                <a16:creationId xmlns:a16="http://schemas.microsoft.com/office/drawing/2014/main" id="{266B99CE-AC46-4A4E-BCF1-0FCF163A980E}"/>
               </a:ext>
             </a:extLst>
           </p:cNvPr>
@@ -10624,7 +10624,7 @@
           <p:cNvPr id="7" name="">
             <a:extLst xmlns:a="http://schemas.openxmlformats.org/drawingml/2006/main">
               <a:ext uri="{FF2B5EF4-FFF2-40B4-BE49-F238E27FC236}">
-                <a16:creationId xmlns:a16="http://schemas.microsoft.com/office/drawing/2014/main" id="{9480DA71-96C1-4B9E-BFE0-00398970B97D}"/>
+                <a16:creationId xmlns:a16="http://schemas.microsoft.com/office/drawing/2014/main" id="{ABD0F22E-E128-4F84-BA8B-B237FEB2DD5B}"/>
               </a:ext>
             </a:extLst>
           </p:cNvPr>
@@ -10753,7 +10753,7 @@
     </p:spTree>
     <p:extLst>
       <p:ext uri="{BB962C8B-B14F-4D97-AF65-F5344CB8AC3E}">
-        <p14:creationId xmlns:p14="http://schemas.microsoft.com/office/powerpoint/2010/main" val="2123935914"/>
+        <p14:creationId xmlns:p14="http://schemas.microsoft.com/office/powerpoint/2010/main" val="1074048494"/>
       </p:ext>
     </p:extLst>
   </p:cSld>

</xml_diff>